<commit_message>
[content] Update security lesson 1: 8 refined roles, new prep doc, regenerated pptx
</commit_message>
<xml_diff>
--- a/projects/ai-training-course/03-security/lesson-1-security.pptx
+++ b/projects/ai-training-course/03-security/lesson-1-security.pptx
@@ -4226,7 +4226,7 @@
               </a:defRPr>
             </a:pPr>
             <a:r>
-              <a:t>Практика 2: Анализ сметы на завышение</a:t>
+              <a:t>Практика 2: Экспертиза договора</a:t>
             </a:r>
           </a:p>
         </p:txBody>
@@ -4270,11 +4270,11 @@
             </a:r>
             <a:br/>
             <a:r>
-              <a:t>• РОЛЬ: Ты — экономист СБ.</a:t>
-            </a:r>
-            <a:br/>
-            <a:r>
-              <a:t>• ЗАДАЧА: Найди необоснованные затраты.</a:t>
+              <a:t>• РОЛЬ: Ты — эксперт по документам СБ.</a:t>
+            </a:r>
+            <a:br/>
+            <a:r>
+              <a:t>• ЗАДАЧА: Найти риски и непрописанные случаи.</a:t>
             </a:r>
             <a:br/>
             <a:r>
@@ -4282,19 +4282,31 @@
             </a:r>
             <a:br/>
             <a:r>
-              <a:t>• Данные:</a:t>
-            </a:r>
-            <a:br/>
-            <a:r>
-              <a:t>• - Бетон Б25: 8500 ₽/м³ (рынок: 7200-7800)</a:t>
-            </a:r>
-            <a:br/>
-            <a:r>
-              <a:t>• - Арматура: 58 000 ₽/т (рынок: 52 000-55 000)</a:t>
-            </a:r>
-            <a:br/>
-            <a:r>
-              <a:t>• - Накладные расходы: 18% (норма: 12-15%)</a:t>
+              <a:t>• Данные договора:</a:t>
+            </a:r>
+            <a:br/>
+            <a:r>
+              <a:t>• - Цена: фиксированная, 50 млн ₽, без индексации</a:t>
+            </a:r>
+            <a:br/>
+            <a:r>
+              <a:t>• - Срок: 180 дней, штраф за просрочку — 0.01% в день</a:t>
+            </a:r>
+            <a:br/>
+            <a:r>
+              <a:t>• - Акты КС-2: принимаются в течение 5 дней без претензий</a:t>
+            </a:r>
+            <a:br/>
+            <a:r>
+              <a:t>• - Форс-мажор: не определён перечень</a:t>
+            </a:r>
+            <a:br/>
+            <a:r>
+              <a:t>• - Гарантия: 1 год (норма — 2-3 года)</a:t>
+            </a:r>
+            <a:br/>
+            <a:r>
+              <a:t>• - Страхование: отсутствует</a:t>
             </a:r>
             <a:br/>
             <a:r>
@@ -4302,19 +4314,7 @@
             </a:r>
             <a:br/>
             <a:r>
-              <a:t>• ФОРМАТ:</a:t>
-            </a:r>
-            <a:br/>
-            <a:r>
-              <a:t>•   1. Таблица сравнения (позиция, цена сметы, рыночная, отклонение)</a:t>
-            </a:r>
-            <a:br/>
-            <a:r>
-              <a:t>•   2. Итоговое завышение</a:t>
-            </a:r>
-            <a:br/>
-            <a:r>
-              <a:t>•   3. Рекомендации</a:t>
+              <a:t>• ФОРМАТ: Риски по пунктам + непрописанные случаи + оценка.</a:t>
             </a:r>
           </a:p>
         </p:txBody>
@@ -4454,7 +4454,7 @@
               </a:defRPr>
             </a:pPr>
             <a:r>
-              <a:t>Практика 3: План расследования</a:t>
+              <a:t>Практика 3: План реагирования на инцидент ИБ</a:t>
             </a:r>
           </a:p>
         </p:txBody>
@@ -4498,11 +4498,11 @@
             </a:r>
             <a:br/>
             <a:r>
-              <a:t>• РОЛЬ: Ты — следователь СБ.</a:t>
-            </a:r>
-            <a:br/>
-            <a:r>
-              <a:t>• ЗАДАЧА: Составить план расследования.</a:t>
+              <a:t>• РОЛЬ: Ты — аналитик ИБ, специалист SOC.</a:t>
+            </a:r>
+            <a:br/>
+            <a:r>
+              <a:t>• ЗАДАЧА: Составить план реагирования.</a:t>
             </a:r>
             <a:br/>
             <a:r>
@@ -4510,7 +4510,7 @@
             </a:r>
             <a:br/>
             <a:r>
-              <a:t>• Инцидент: Пропажа кабеля со склада (500 м, ~200 тыс ₽).</a:t>
+              <a:t>• Инцидент: Подозрение на утечку коммерческой тайны.</a:t>
             </a:r>
             <a:br/>
             <a:r>
@@ -4518,23 +4518,27 @@
             </a:r>
             <a:br/>
             <a:r>
-              <a:t>• Известно:</a:t>
-            </a:r>
-            <a:br/>
-            <a:r>
-              <a:t>• - Последняя инвентаризация: 2 недели назад</a:t>
-            </a:r>
-            <a:br/>
-            <a:r>
-              <a:t>• - Доступ на склад: 5 человек</a:t>
-            </a:r>
-            <a:br/>
-            <a:r>
-              <a:t>• - Камеры: 3 шт, запись 14 дней</a:t>
-            </a:r>
-            <a:br/>
-            <a:r>
-              <a:t>• - Сигнализация срабатывала 1 раз 5 дней назад</a:t>
+              <a:t>• Данные:</a:t>
+            </a:r>
+            <a:br/>
+            <a:r>
+              <a:t>• - Конкурент опубликовал прайс, идентичный внутренней версии</a:t>
+            </a:r>
+            <a:br/>
+            <a:r>
+              <a:t>• - Доступ к прайсу: 12 сотрудников</a:t>
+            </a:r>
+            <a:br/>
+            <a:r>
+              <a:t>• - Логи DLP: 3 сотрудника скачивали файл за месяц</a:t>
+            </a:r>
+            <a:br/>
+            <a:r>
+              <a:t>• - Один из 3 уволился 2 недели назад</a:t>
+            </a:r>
+            <a:br/>
+            <a:r>
+              <a:t>• - Прайс был отправлен на личную почту (по DLP)</a:t>
             </a:r>
             <a:br/>
             <a:r>
@@ -4542,7 +4546,7 @@
             </a:r>
             <a:br/>
             <a:r>
-              <a:t>• ФОРМАТ: План (этап, что делать, срок) + вопросы для 5 человек.</a:t>
+              <a:t>• ФОРМАТ: Хронология + круг подозреваемых + план + профилактика.</a:t>
             </a:r>
           </a:p>
         </p:txBody>
@@ -4734,7 +4738,7 @@
             </a:r>
             <a:br/>
             <a:r>
-              <a:t>• УРОВЕНЬ 2 → ИИ с файлами: выписки, видео, сметы. Интеграции.</a:t>
+              <a:t>• УРОВЕНЬ 2 → ИИ с файлами: выписки, видео, сметы, договоры. Интеграции.</a:t>
             </a:r>
             <a:br/>
             <a:r>
@@ -4754,7 +4758,7 @@
             </a:r>
             <a:br/>
             <a:r>
-              <a:t>•   • Агент сам находит связи в новых данных</a:t>
+              <a:t>•   • Агент анализирует логи DLP и фаерволов</a:t>
             </a:r>
             <a:br/>
             <a:r>
@@ -5119,7 +5123,7 @@
               </a:defRPr>
             </a:pPr>
             <a:r>
-              <a:t>ИИ — как детектор лжи для аналитика.</a:t>
+              <a:t>ИИ — как детектор лжи для аналитика СБ.</a:t>
             </a:r>
             <a:br/>
             <a:r>
@@ -5307,7 +5311,7 @@
             </a:r>
             <a:br/>
             <a:r>
-              <a:t>• УРОВЕНЬ 2: ИИ с файлами — выписки, видео, сметы. Интеграции</a:t>
+              <a:t>• УРОВЕНЬ 2: ИИ с файлами — выписки, видео, сметы, договоры. Интеграции</a:t>
             </a:r>
             <a:br/>
             <a:r>
@@ -5553,7 +5557,7 @@
                         </a:defRPr>
                       </a:pPr>
                       <a:r>
-                        <a:t>Физическая безопасность</a:t>
+                        <a:t>Контроль ТСО (СКУД, камеры, периметр)</a:t>
                       </a:r>
                     </a:p>
                   </a:txBody>
@@ -5576,7 +5580,7 @@
                         </a:defRPr>
                       </a:pPr>
                       <a:r>
-                        <a:t>Просматривать записи с камер вручную</a:t>
+                        <a:t>Просматривать записи вручную, сверять журналы</a:t>
                       </a:r>
                     </a:p>
                   </a:txBody>
@@ -5599,7 +5603,7 @@
                         </a:defRPr>
                       </a:pPr>
                       <a:r>
-                        <a:t>Загрузил видео → отчёт с аномалиями за 5 мин</a:t>
+                        <a:t>Загрузил видео/журналы → отчёт с аномалиями</a:t>
                       </a:r>
                     </a:p>
                   </a:txBody>
@@ -5647,7 +5651,7 @@
                         </a:defRPr>
                       </a:pPr>
                       <a:r>
-                        <a:t>Кадровая безопасность</a:t>
+                        <a:t>Изучение кандидатов и стажёров</a:t>
                       </a:r>
                     </a:p>
                   </a:txBody>
@@ -5835,7 +5839,7 @@
                         </a:defRPr>
                       </a:pPr>
                       <a:r>
-                        <a:t>Экономическая безопасность</a:t>
+                        <a:t>Проверка закупочной деятельности</a:t>
                       </a:r>
                     </a:p>
                   </a:txBody>
@@ -5858,7 +5862,7 @@
                         </a:defRPr>
                       </a:pPr>
                       <a:r>
-                        <a:t>Сверять сметы с ФЕР, искать цены</a:t>
+                        <a:t>Сверять сметы, искать цены, проверять процедуры</a:t>
                       </a:r>
                     </a:p>
                   </a:txBody>
@@ -5881,7 +5885,7 @@
                         </a:defRPr>
                       </a:pPr>
                       <a:r>
-                        <a:t>Загрузил смету → таблица завышений за 2 мин</a:t>
+                        <a:t>Загрузил смету → таблица завышений</a:t>
                       </a:r>
                     </a:p>
                   </a:txBody>
@@ -5929,7 +5933,7 @@
                         </a:defRPr>
                       </a:pPr>
                       <a:r>
-                        <a:t>Анализ взаимосвязей</a:t>
+                        <a:t>Проверка взаимосвязей</a:t>
                       </a:r>
                     </a:p>
                   </a:txBody>
@@ -6023,7 +6027,7 @@
                         </a:defRPr>
                       </a:pPr>
                       <a:r>
-                        <a:t>Внутренние расследования</a:t>
+                        <a:t>Служебные расследования</a:t>
                       </a:r>
                     </a:p>
                   </a:txBody>
@@ -6069,7 +6073,7 @@
                         </a:defRPr>
                       </a:pPr>
                       <a:r>
-                        <a:t>Описал инцидент → план + хронология</a:t>
+                        <a:t>Описал инцидент → план + хронология + версии</a:t>
                       </a:r>
                     </a:p>
                   </a:txBody>
@@ -6117,7 +6121,7 @@
                         </a:defRPr>
                       </a:pPr>
                       <a:r>
-                        <a:t>Информационная безопасность</a:t>
+                        <a:t>Разработка, оценка, экспертиза документов</a:t>
                       </a:r>
                     </a:p>
                   </a:txBody>
@@ -6140,7 +6144,7 @@
                         </a:defRPr>
                       </a:pPr>
                       <a:r>
-                        <a:t>Просматривать логи вручную</a:t>
+                        <a:t>Читать договоры/сметы вручную, искать риски</a:t>
                       </a:r>
                     </a:p>
                   </a:txBody>
@@ -6163,7 +6167,7 @@
                         </a:defRPr>
                       </a:pPr>
                       <a:r>
-                        <a:t>Загрузил логи → алерты на аномалии</a:t>
+                        <a:t>Загрузил документ → список рисков + правки</a:t>
                       </a:r>
                     </a:p>
                   </a:txBody>
@@ -6211,7 +6215,7 @@
                         </a:defRPr>
                       </a:pPr>
                       <a:r>
-                        <a:t>Аналитика и разведка</a:t>
+                        <a:t>Информационная безопасность</a:t>
                       </a:r>
                     </a:p>
                   </a:txBody>
@@ -6234,7 +6238,7 @@
                         </a:defRPr>
                       </a:pPr>
                       <a:r>
-                        <a:t>Мониторить источники вручную</a:t>
+                        <a:t>Просматривать логи, анализировать DLP</a:t>
                       </a:r>
                     </a:p>
                   </a:txBody>
@@ -6257,7 +6261,7 @@
                         </a:defRPr>
                       </a:pPr>
                       <a:r>
-                        <a:t>Задал критерии → дайджест угроз</a:t>
+                        <a:t>Загрузил логи → алерты на аномалии</a:t>
                       </a:r>
                     </a:p>
                   </a:txBody>
@@ -6280,7 +6284,7 @@
                         </a:defRPr>
                       </a:pPr>
                       <a:r>
-                        <a:t>4-6 часов</a:t>
+                        <a:t>2-3 часа</a:t>
                       </a:r>
                     </a:p>
                   </a:txBody>
@@ -6430,7 +6434,7 @@
               </a:defRPr>
             </a:pPr>
             <a:r>
-              <a:t>Пример: Физическая безопасность</a:t>
+              <a:t>Пример: Контроль технических средств охраны</a:t>
             </a:r>
           </a:p>
         </p:txBody>
@@ -6502,7 +6506,7 @@
               </a:defRPr>
             </a:pPr>
             <a:r>
-              <a:t>• БЫЛО: 3-4 часа на проверку записей</a:t>
+              <a:t>• БЫЛО: 3-4 часа на проверку записей и журналов</a:t>
             </a:r>
             <a:br/>
             <a:r>
@@ -6510,7 +6514,7 @@
             </a:r>
             <a:br/>
             <a:r>
-              <a:t>•   • Сверять журналы патрулей</a:t>
+              <a:t>•   • Сверять журналы патрулей и СКУД</a:t>
             </a:r>
             <a:br/>
             <a:r>
@@ -6526,7 +6530,7 @@
             </a:r>
             <a:br/>
             <a:r>
-              <a:t>•   • Загрузил видео в ИИ</a:t>
+              <a:t>•   • Загрузил видео и журналы в ИИ</a:t>
             </a:r>
             <a:br/>
             <a:r>
@@ -6938,7 +6942,7 @@
               </a:defRPr>
             </a:pPr>
             <a:r>
-              <a:t>Пример: Экономическая безопасность</a:t>
+              <a:t>Пример: Разработка, оценка и экспертиза документов</a:t>
             </a:r>
           </a:p>
         </p:txBody>
@@ -6974,7 +6978,7 @@
               </a:defRPr>
             </a:pPr>
             <a:r>
-              <a:t>Экономия: 3-5 часов на смету</a:t>
+              <a:t>Экономия: 2-3 часа на документ</a:t>
             </a:r>
           </a:p>
         </p:txBody>
@@ -7010,19 +7014,19 @@
               </a:defRPr>
             </a:pPr>
             <a:r>
-              <a:t>• БЫЛО: 3-5 часов на проверку сметы</a:t>
-            </a:r>
-            <a:br/>
-            <a:r>
-              <a:t>•   • Сверять смету с ФЕР вручную</a:t>
-            </a:r>
-            <a:br/>
-            <a:r>
-              <a:t>•   • Искать рыночные цены</a:t>
-            </a:r>
-            <a:br/>
-            <a:r>
-              <a:t>•   • Считать переплаты</a:t>
+              <a:t>• БЫЛО: 2-3 часа на экспертизу договора</a:t>
+            </a:r>
+            <a:br/>
+            <a:r>
+              <a:t>•   • Читать договор вручную</a:t>
+            </a:r>
+            <a:br/>
+            <a:r>
+              <a:t>•   • Искать риски и непрописанные случаи</a:t>
+            </a:r>
+            <a:br/>
+            <a:r>
+              <a:t>•   • Писать замечания и правки</a:t>
             </a:r>
             <a:br/>
             <a:r>
@@ -7030,19 +7034,19 @@
             </a:r>
             <a:br/>
             <a:r>
-              <a:t>• СТАЛО: 2 минуты + 10 минут проверки</a:t>
-            </a:r>
-            <a:br/>
-            <a:r>
-              <a:t>•   • Загрузил смету в ИИ</a:t>
-            </a:r>
-            <a:br/>
-            <a:r>
-              <a:t>•   • Получил таблицу завышений</a:t>
-            </a:r>
-            <a:br/>
-            <a:r>
-              <a:t>•   • Получил итоговую сумму переплаты</a:t>
+              <a:t>• СТАЛО: 3 минуты + 10 минут проверки</a:t>
+            </a:r>
+            <a:br/>
+            <a:r>
+              <a:t>•   • Загрузил договор в ИИ</a:t>
+            </a:r>
+            <a:br/>
+            <a:r>
+              <a:t>•   • Получил список рисков по пунктам</a:t>
+            </a:r>
+            <a:br/>
+            <a:r>
+              <a:t>•   • Получил рекомендуемые правки</a:t>
             </a:r>
             <a:br/>
             <a:r>
@@ -7050,7 +7054,7 @@
             </a:r>
             <a:br/>
             <a:r>
-              <a:t>• ИИ считает. СБ решает, оспаривать или нет.</a:t>
+              <a:t>• ИИ находит. СБ оценивает и требует правки.</a:t>
             </a:r>
           </a:p>
         </p:txBody>
@@ -7551,7 +7555,7 @@
             </a:r>
             <a:br/>
             <a:r>
-              <a:t>• Для проверок, инцидентов, связей, смет</a:t>
+              <a:t>• Для проверок, инцидентов, связей, смет, договоров</a:t>
             </a:r>
           </a:p>
         </p:txBody>
@@ -7747,7 +7751,7 @@
             </a:r>
             <a:br/>
             <a:r>
-              <a:t>• • Скрепка 📎 — загрузить файл (смету, выписку, фото)</a:t>
+              <a:t>• • Скрепка 📎 — загрузить файл (смету, выписку, договор, фото)</a:t>
             </a:r>
             <a:br/>
             <a:r>

</xml_diff>